<commit_message>
OLD_FILE, but useful summary tables
</commit_message>
<xml_diff>
--- a/Assignment/zBMI_24m Clustering Graphs.pptx
+++ b/Assignment/zBMI_24m Clustering Graphs.pptx
@@ -222,7 +222,7 @@
           <a:p>
             <a:fld id="{FFDE3B6A-1818-454F-B66A-F376DC516B39}" type="datetimeFigureOut">
               <a:rPr lang="en-CA" smtClean="0"/>
-              <a:t>2026-04-05</a:t>
+              <a:t>2026-04-07</a:t>
             </a:fld>
             <a:endParaRPr lang="en-CA"/>
           </a:p>
@@ -2089,7 +2089,7 @@
           <a:p>
             <a:r>
               <a:rPr lang="en-US" b="1" dirty="0"/>
-              <a:t>Graph 20. Internal validation of zBMI_24m clusters (black = hierarchical, pink = k-means, green = PAM)</a:t>
+              <a:t>Graph 20. Internal validation of zBMI_24m clusters (black = hierarchical, red = k-means, green = PAM)</a:t>
             </a:r>
           </a:p>
           <a:p>
@@ -3170,7 +3170,7 @@
           <a:p>
             <a:fld id="{18BF30BC-E745-4854-B6E6-071AEEFCBC00}" type="datetimeFigureOut">
               <a:rPr lang="en-CA" smtClean="0"/>
-              <a:t>2026-04-05</a:t>
+              <a:t>2026-04-07</a:t>
             </a:fld>
             <a:endParaRPr lang="en-CA"/>
           </a:p>
@@ -3370,7 +3370,7 @@
           <a:p>
             <a:fld id="{18BF30BC-E745-4854-B6E6-071AEEFCBC00}" type="datetimeFigureOut">
               <a:rPr lang="en-CA" smtClean="0"/>
-              <a:t>2026-04-05</a:t>
+              <a:t>2026-04-07</a:t>
             </a:fld>
             <a:endParaRPr lang="en-CA"/>
           </a:p>
@@ -3580,7 +3580,7 @@
           <a:p>
             <a:fld id="{18BF30BC-E745-4854-B6E6-071AEEFCBC00}" type="datetimeFigureOut">
               <a:rPr lang="en-CA" smtClean="0"/>
-              <a:t>2026-04-05</a:t>
+              <a:t>2026-04-07</a:t>
             </a:fld>
             <a:endParaRPr lang="en-CA"/>
           </a:p>
@@ -3780,7 +3780,7 @@
           <a:p>
             <a:fld id="{18BF30BC-E745-4854-B6E6-071AEEFCBC00}" type="datetimeFigureOut">
               <a:rPr lang="en-CA" smtClean="0"/>
-              <a:t>2026-04-05</a:t>
+              <a:t>2026-04-07</a:t>
             </a:fld>
             <a:endParaRPr lang="en-CA"/>
           </a:p>
@@ -4056,7 +4056,7 @@
           <a:p>
             <a:fld id="{18BF30BC-E745-4854-B6E6-071AEEFCBC00}" type="datetimeFigureOut">
               <a:rPr lang="en-CA" smtClean="0"/>
-              <a:t>2026-04-05</a:t>
+              <a:t>2026-04-07</a:t>
             </a:fld>
             <a:endParaRPr lang="en-CA"/>
           </a:p>
@@ -4324,7 +4324,7 @@
           <a:p>
             <a:fld id="{18BF30BC-E745-4854-B6E6-071AEEFCBC00}" type="datetimeFigureOut">
               <a:rPr lang="en-CA" smtClean="0"/>
-              <a:t>2026-04-05</a:t>
+              <a:t>2026-04-07</a:t>
             </a:fld>
             <a:endParaRPr lang="en-CA"/>
           </a:p>
@@ -4739,7 +4739,7 @@
           <a:p>
             <a:fld id="{18BF30BC-E745-4854-B6E6-071AEEFCBC00}" type="datetimeFigureOut">
               <a:rPr lang="en-CA" smtClean="0"/>
-              <a:t>2026-04-05</a:t>
+              <a:t>2026-04-07</a:t>
             </a:fld>
             <a:endParaRPr lang="en-CA"/>
           </a:p>
@@ -4881,7 +4881,7 @@
           <a:p>
             <a:fld id="{18BF30BC-E745-4854-B6E6-071AEEFCBC00}" type="datetimeFigureOut">
               <a:rPr lang="en-CA" smtClean="0"/>
-              <a:t>2026-04-05</a:t>
+              <a:t>2026-04-07</a:t>
             </a:fld>
             <a:endParaRPr lang="en-CA"/>
           </a:p>
@@ -4994,7 +4994,7 @@
           <a:p>
             <a:fld id="{18BF30BC-E745-4854-B6E6-071AEEFCBC00}" type="datetimeFigureOut">
               <a:rPr lang="en-CA" smtClean="0"/>
-              <a:t>2026-04-05</a:t>
+              <a:t>2026-04-07</a:t>
             </a:fld>
             <a:endParaRPr lang="en-CA"/>
           </a:p>
@@ -5307,7 +5307,7 @@
           <a:p>
             <a:fld id="{18BF30BC-E745-4854-B6E6-071AEEFCBC00}" type="datetimeFigureOut">
               <a:rPr lang="en-CA" smtClean="0"/>
-              <a:t>2026-04-05</a:t>
+              <a:t>2026-04-07</a:t>
             </a:fld>
             <a:endParaRPr lang="en-CA"/>
           </a:p>
@@ -5596,7 +5596,7 @@
           <a:p>
             <a:fld id="{18BF30BC-E745-4854-B6E6-071AEEFCBC00}" type="datetimeFigureOut">
               <a:rPr lang="en-CA" smtClean="0"/>
-              <a:t>2026-04-05</a:t>
+              <a:t>2026-04-07</a:t>
             </a:fld>
             <a:endParaRPr lang="en-CA"/>
           </a:p>
@@ -5839,7 +5839,7 @@
           <a:p>
             <a:fld id="{18BF30BC-E745-4854-B6E6-071AEEFCBC00}" type="datetimeFigureOut">
               <a:rPr lang="en-CA" smtClean="0"/>
-              <a:t>2026-04-05</a:t>
+              <a:t>2026-04-07</a:t>
             </a:fld>
             <a:endParaRPr lang="en-CA"/>
           </a:p>
@@ -8206,14 +8206,14 @@
           <p:nvPr>
             <p:extLst>
               <p:ext uri="{D42A27DB-BD31-4B8C-83A1-F6EECF244321}">
-                <p14:modId xmlns:p14="http://schemas.microsoft.com/office/powerpoint/2010/main" val="2564443412"/>
+                <p14:modId xmlns:p14="http://schemas.microsoft.com/office/powerpoint/2010/main" val="587823572"/>
               </p:ext>
             </p:extLst>
           </p:nvPr>
         </p:nvGraphicFramePr>
         <p:xfrm>
-          <a:off x="801315" y="753000"/>
-          <a:ext cx="10589368" cy="4652628"/>
+          <a:off x="801316" y="803422"/>
+          <a:ext cx="10589368" cy="4486695"/>
         </p:xfrm>
         <a:graphic>
           <a:graphicData uri="http://schemas.openxmlformats.org/drawingml/2006/table">
@@ -8295,7 +8295,7 @@
                       <a:pPr algn="ctr"/>
                       <a:r>
                         <a:rPr lang="en-CA" dirty="0"/>
-                        <a:t>Around Medoids (PAM )</a:t>
+                        <a:t>Around Medoids (PAM)</a:t>
                       </a:r>
                     </a:p>
                   </a:txBody>
@@ -8348,7 +8348,7 @@
                       <a:pPr algn="ctr"/>
                       <a:r>
                         <a:rPr lang="en-US" sz="1600" dirty="0"/>
-                        <a:t>Tells you the average zBMI of each group</a:t>
+                        <a:t>Average zBMI of each group</a:t>
                       </a:r>
                       <a:endParaRPr lang="en-CA" sz="1600" dirty="0"/>
                     </a:p>
@@ -8370,7 +8370,7 @@
                       <a:pPr algn="ctr"/>
                       <a:r>
                         <a:rPr lang="en-US" sz="1600" dirty="0"/>
-                        <a:t>Uses real children as cluster centers</a:t>
+                        <a:t>Real children as cluster centers</a:t>
                       </a:r>
                       <a:endParaRPr lang="en-CA" sz="1600" dirty="0"/>
                     </a:p>
@@ -8392,7 +8392,7 @@
                       <a:pPr algn="ctr"/>
                       <a:r>
                         <a:rPr lang="en-US" sz="1600" dirty="0"/>
-                        <a:t>A tree (dendrogram) showing how children are progressively grouped together</a:t>
+                        <a:t>A dendrogram showing how children are progressively grouped together</a:t>
                       </a:r>
                       <a:endParaRPr lang="en-CA" sz="1600" dirty="0"/>
                     </a:p>
@@ -11609,6 +11609,58 @@
           </a:p>
         </p:txBody>
       </p:sp>
+      <p:sp>
+        <p:nvSpPr>
+          <p:cNvPr id="5" name="Rectangle 4">
+            <a:extLst>
+              <a:ext uri="{FF2B5EF4-FFF2-40B4-BE49-F238E27FC236}">
+                <a16:creationId xmlns:a16="http://schemas.microsoft.com/office/drawing/2014/main" id="{C57BAF59-1CF0-C9D2-17D2-B993B9B8879F}"/>
+              </a:ext>
+            </a:extLst>
+          </p:cNvPr>
+          <p:cNvSpPr/>
+          <p:nvPr/>
+        </p:nvSpPr>
+        <p:spPr>
+          <a:xfrm>
+            <a:off x="1126160" y="1401387"/>
+            <a:ext cx="9688230" cy="4413004"/>
+          </a:xfrm>
+          <a:prstGeom prst="rect">
+            <a:avLst/>
+          </a:prstGeom>
+          <a:noFill/>
+          <a:ln>
+            <a:solidFill>
+              <a:schemeClr val="tx1"/>
+            </a:solidFill>
+          </a:ln>
+        </p:spPr>
+        <p:style>
+          <a:lnRef idx="2">
+            <a:schemeClr val="accent1">
+              <a:shade val="15000"/>
+            </a:schemeClr>
+          </a:lnRef>
+          <a:fillRef idx="1">
+            <a:schemeClr val="accent1"/>
+          </a:fillRef>
+          <a:effectRef idx="0">
+            <a:schemeClr val="accent1"/>
+          </a:effectRef>
+          <a:fontRef idx="minor">
+            <a:schemeClr val="lt1"/>
+          </a:fontRef>
+        </p:style>
+        <p:txBody>
+          <a:bodyPr rtlCol="0" anchor="ctr"/>
+          <a:lstStyle/>
+          <a:p>
+            <a:pPr algn="ctr"/>
+            <a:endParaRPr lang="en-CA"/>
+          </a:p>
+        </p:txBody>
+      </p:sp>
     </p:spTree>
     <p:extLst>
       <p:ext uri="{BB962C8B-B14F-4D97-AF65-F5344CB8AC3E}">

</xml_diff>